<commit_message>
Corrige CI do backend Python (ModuleNotFoundError) e ajusta slides da Atividade 4
O job "Backend (pytest)" falhava desde o primeiro PR (agosto) porque o
pytest, invocado como comando direto (nao "python -m pytest"), usa o
diretorio do proprio executavel como sys.path[0], nao o cwd - entao
"from app.db import ..." em tests/conftest.py nunca encontrava o pacote
app. Localmente sempre rodamos com "python -m pytest", que mascarava o
problema. Corrigido com backend/pytest.ini (pythonpath = .). Validado
simulando a condicao exata do CI (script rodando fora do diretorio do
projeto): 81 testes passam, sem ModuleNotFoundError.

Slides da Atividade 4: removidos os travessoes (—) do texto, trocados por
pontuacao mais natural (dois-pontos, virgula, ponto final).
</commit_message>
<xml_diff>
--- a/docs/atividade4/SLIDES_ATIVIDADE4.pptx
+++ b/docs/atividade4/SLIDES_ATIVIDADE4.pptx
@@ -1829,7 +1829,7 @@
                 <a:ea typeface="Calibri" pitchFamily="34" charset="-122"/>
                 <a:cs typeface="Calibri" pitchFamily="34" charset="-120"/>
               </a:rPr>
-              <a:t>Smart HAS — AI Logistics Extension</a:t>
+              <a:t>Smart HAS: AI Logistics Extension</a:t>
             </a:r>
             <a:endParaRPr lang="en-US" sz="1900" dirty="0"/>
           </a:p>
@@ -1868,7 +1868,7 @@
                 <a:ea typeface="Calibri" pitchFamily="34" charset="-122"/>
                 <a:cs typeface="Calibri" pitchFamily="34" charset="-120"/>
               </a:rPr>
-              <a:t>Enterprise Challenge · Leroy Merlin — produto concluído</a:t>
+              <a:t>Enterprise Challenge · Leroy Merlin · Produto concluído</a:t>
             </a:r>
             <a:endParaRPr lang="en-US" sz="1700" dirty="0"/>
           </a:p>
@@ -1943,7 +1943,7 @@
                 <a:ea typeface="Calibri" pitchFamily="34" charset="-122"/>
                 <a:cs typeface="Calibri" pitchFamily="34" charset="-120"/>
               </a:rPr>
-              <a:t>[LINK DO VÍDEO — preencher após publicar]</a:t>
+              <a:t>[LINK DO VÍDEO: preencher após publicar]</a:t>
             </a:r>
             <a:endParaRPr lang="en-US" sz="1300" dirty="0"/>
           </a:p>
@@ -3020,7 +3020,7 @@
                 <a:ea typeface="Calibri" pitchFamily="34" charset="-122"/>
                 <a:cs typeface="Calibri" pitchFamily="34" charset="-120"/>
               </a:rPr>
-              <a:t>Milhões de idosos e pessoas com baixa escolaridade não conseguem acessar serviços públicos essenciais — e, quando conseguem, não têm como acompanhar se o suporte ou o pedido que precisam realmente chegou até eles.</a:t>
+              <a:t>Milhões de idosos e pessoas com baixa escolaridade não conseguem acessar serviços públicos essenciais. Quando conseguem, não têm como acompanhar se o suporte ou o pedido que precisam realmente chegou até eles.</a:t>
             </a:r>
             <a:endParaRPr lang="en-US" sz="1600" dirty="0"/>
           </a:p>
@@ -3106,7 +3106,7 @@
                 <a:ea typeface="Calibri" pitchFamily="34" charset="-122"/>
                 <a:cs typeface="Calibri" pitchFamily="34" charset="-120"/>
               </a:rPr>
-              <a:t>aplicar Logística Inteligente e Experiência de Entrega 5.0 sobre essa jornada — o conteúdo certo, ao usuário certo, no momento certo.</a:t>
+              <a:t>aplicar Logística Inteligente e Experiência de Entrega 5.0 sobre essa jornada: o conteúdo certo, ao usuário certo, no momento certo.</a:t>
             </a:r>
             <a:endParaRPr lang="en-US" sz="1300" dirty="0"/>
           </a:p>
@@ -3747,7 +3747,7 @@
                 <a:ea typeface="Calibri" pitchFamily="34" charset="-122"/>
                 <a:cs typeface="Calibri" pitchFamily="34" charset="-120"/>
               </a:rPr>
-              <a:t>Conteúdo certo, usuário certo, momento certo — online ou offline.</a:t>
+              <a:t>Conteúdo certo, usuário certo, momento certo, online ou offline.</a:t>
             </a:r>
             <a:endParaRPr lang="en-US" sz="1200" dirty="0"/>
           </a:p>
@@ -4087,7 +4087,7 @@
                 <a:ea typeface="Calibri" pitchFamily="34" charset="-122"/>
                 <a:cs typeface="Calibri" pitchFamily="34" charset="-120"/>
               </a:rPr>
-              <a:t>Poder computacional concentrado nos picos e cenários de alta variabilidade — onde o impacto é maior.</a:t>
+              <a:t>Poder computacional concentrado nos picos e cenários de alta variabilidade, onde o impacto é maior.</a:t>
             </a:r>
             <a:endParaRPr lang="en-US" sz="1200" dirty="0"/>
           </a:p>
@@ -4466,7 +4466,7 @@
                 <a:ea typeface="Calibri" pitchFamily="34" charset="-122"/>
                 <a:cs typeface="Calibri" pitchFamily="34" charset="-120"/>
               </a:rPr>
-              <a:t>API original do app — hospeda os motores de IA (detalhes no próximo slide).</a:t>
+              <a:t>API original do app: hospeda os motores de IA (detalhes no próximo slide).</a:t>
             </a:r>
             <a:endParaRPr lang="en-US" sz="1150" dirty="0"/>
           </a:p>
@@ -4570,7 +4570,7 @@
                 <a:ea typeface="Calibri" pitchFamily="34" charset="-122"/>
                 <a:cs typeface="Calibri" pitchFamily="34" charset="-120"/>
               </a:rPr>
-              <a:t>33 endpoints, JWT, H2, Swagger — mesma camada de AI Logistics exposta com robustez.</a:t>
+              <a:t>33 endpoints, JWT, H2, Swagger. Mesma camada de AI Logistics exposta com robustez.</a:t>
             </a:r>
             <a:endParaRPr lang="en-US" sz="1150" dirty="0"/>
           </a:p>
@@ -4968,7 +4968,7 @@
                 <a:ea typeface="Calibri" pitchFamily="34" charset="-122"/>
                 <a:cs typeface="Calibri" pitchFamily="34" charset="-120"/>
               </a:rPr>
-              <a:t>Motor de Recomendação — ML real</a:t>
+              <a:t>Motor de Recomendação (ML real)</a:t>
             </a:r>
             <a:endParaRPr lang="en-US" sz="1500" dirty="0"/>
           </a:p>
@@ -5010,7 +5010,7 @@
                 <a:ea typeface="Calibri" pitchFamily="34" charset="-122"/>
                 <a:cs typeface="Calibri" pitchFamily="34" charset="-120"/>
               </a:rPr>
-              <a:t>Filtragem colaborativa item-a-item (similaridade de cosseno) quando há uso de mais de um usuário; heurística de frequência/novidade como fallback quando não há dado suficiente. Testado.</a:t>
+              <a:t>Filtragem colaborativa item a item (similaridade de cosseno) quando há uso de mais de um usuário; heurística de frequência/novidade como fallback quando não há dado suficiente. Testado.</a:t>
             </a:r>
             <a:endParaRPr lang="en-US" sz="1250" dirty="0"/>
           </a:p>
@@ -5262,7 +5262,7 @@
                 <a:ea typeface="Calibri" pitchFamily="34" charset="-122"/>
                 <a:cs typeface="Calibri" pitchFamily="34" charset="-120"/>
               </a:rPr>
-              <a:t>Painel mostra ao usuário onde está, o que conquistou e o próximo passo — o mesmo princípio de rastreio de um pedido logístico.</a:t>
+              <a:t>Painel mostra ao usuário onde está, o que conquistou e o próximo passo, o mesmo princípio de rastreio de um pedido logístico.</a:t>
             </a:r>
             <a:endParaRPr lang="en-US" sz="1250" dirty="0"/>
           </a:p>
@@ -5933,7 +5933,7 @@
                 <a:ea typeface="Calibri" pitchFamily="34" charset="-122"/>
                 <a:cs typeface="Calibri" pitchFamily="34" charset="-120"/>
               </a:rPr>
-              <a:t>Painel de impacto — no app (cidadão) e no dashboard (parceiro)</a:t>
+              <a:t>Painel de impacto: no app (cidadão) e no dashboard (parceiro)</a:t>
             </a:r>
             <a:endParaRPr lang="en-US" sz="1200" dirty="0"/>
           </a:p>
@@ -6791,7 +6791,7 @@
                 <a:ea typeface="Calibri" pitchFamily="34" charset="-122"/>
                 <a:cs typeface="Calibri" pitchFamily="34" charset="-120"/>
               </a:rPr>
-              <a:t>Sim — desenho nativo</a:t>
+              <a:t>Sim, desenho nativo</a:t>
             </a:r>
             <a:endParaRPr lang="en-US" sz="1050" dirty="0"/>
           </a:p>
@@ -7047,7 +7047,7 @@
                 <a:ea typeface="Calibri" pitchFamily="34" charset="-122"/>
                 <a:cs typeface="Calibri" pitchFamily="34" charset="-120"/>
               </a:rPr>
-              <a:t>Sim — offline-first</a:t>
+              <a:t>Sim, offline-first</a:t>
             </a:r>
             <a:endParaRPr lang="en-US" sz="1050" dirty="0"/>
           </a:p>
@@ -7303,7 +7303,7 @@
                 <a:ea typeface="Calibri" pitchFamily="34" charset="-122"/>
                 <a:cs typeface="Calibri" pitchFamily="34" charset="-120"/>
               </a:rPr>
-              <a:t>Sim — foco em picos</a:t>
+              <a:t>Sim, foco em picos</a:t>
             </a:r>
             <a:endParaRPr lang="en-US" sz="1050" dirty="0"/>
           </a:p>
@@ -7559,7 +7559,7 @@
                 <a:ea typeface="Calibri" pitchFamily="34" charset="-122"/>
                 <a:cs typeface="Calibri" pitchFamily="34" charset="-120"/>
               </a:rPr>
-              <a:t>Sim — único no segmento</a:t>
+              <a:t>Sim, único no segmento</a:t>
             </a:r>
             <a:endParaRPr lang="en-US" sz="1050" dirty="0"/>
           </a:p>
@@ -7750,7 +7750,7 @@
                 <a:ea typeface="Cambria" pitchFamily="34" charset="-122"/>
                 <a:cs typeface="Cambria" pitchFamily="34" charset="-120"/>
               </a:rPr>
-              <a:t>Pra Leroy Merlin, isso significa levar a mesma confiabilidade de uma entrega logística de qualidade pra jornada de inclusão digital de milhões de pessoas — transformando um problema social em um canal de relacionamento pós-venda acessível.</a:t>
+              <a:t>Pra Leroy Merlin, isso significa levar a mesma confiabilidade de uma entrega logística de qualidade pra jornada de inclusão digital de milhões de pessoas, transformando um problema social em um canal de relacionamento pós-venda acessível.</a:t>
             </a:r>
             <a:endParaRPr lang="en-US" sz="1900" dirty="0"/>
           </a:p>
@@ -7789,7 +7789,7 @@
                 <a:ea typeface="Calibri" pitchFamily="34" charset="-122"/>
                 <a:cs typeface="Calibri" pitchFamily="34" charset="-120"/>
               </a:rPr>
-              <a:t>É isso que torna essa solução relevante como produto — não só como projeto acadêmico.</a:t>
+              <a:t>É isso que torna essa solução relevante como produto, não só como projeto acadêmico.</a:t>
             </a:r>
             <a:endParaRPr lang="en-US" sz="1500" dirty="0"/>
           </a:p>

</xml_diff>